<commit_message>
Add GitHub repository link to report and README
</commit_message>
<xml_diff>
--- a/presentation/BLM308_Final_Presentation.pptx
+++ b/presentation/BLM308_Final_Presentation.pptx
@@ -3146,6 +3146,11 @@
           <a:p>
             <a:r>
               <a:t>Emre Kaya | 231041045 | Mayıs 2026</a:t>
+            </a:r>
+          </a:p>
+          <a:p>
+            <a:r>
+              <a:t>https://github.com/emrekayy/blm308-urun-iade-tahmini</a:t>
             </a:r>
           </a:p>
         </p:txBody>

</xml_diff>